<commit_message>
Pitch: slides only (remove the script and speaker notes from main)
Co-Authored-By: Claude Opus 5.5 <noreply@anthropic.com>
</commit_message>
<xml_diff>
--- a/submission/pitch/BernMatch_pitch.pptx
+++ b/submission/pitch/BernMatch_pitch.pptx
@@ -742,11 +742,7 @@
         <p:txBody>
           <a:bodyPr/>
           <a:lstStyle/>
-          <a:p>
-            <a:r>
-              <a:t>[0:00 · 15 s] A Bern start-up is building a needle-free glucose sensor and needs a research partner. The right group exists in Bern; finding it is the hard part. We're Dimitry, Maxim and Ruihan, and this is Bern Match.</a:t>
-            </a:r>
-          </a:p>
+          <a:p/>
         </p:txBody>
       </p:sp>
     </p:spTree>
@@ -812,11 +808,7 @@
         <p:txBody>
           <a:bodyPr/>
           <a:lstStyle/>
-          <a:p>
-            <a:r>
-              <a:t>[2:55 · 20 s] On a frozen test set of real questions in five languages: [click] 82% of expected experts in the top ten, [click] 100% of results linked to a source, [click] zero quotes that differ from the source, [click] zero of 18 red-team attacks. [click] We ship only what the numbers support.</a:t>
-            </a:r>
-          </a:p>
+          <a:p/>
         </p:txBody>
       </p:sp>
     </p:spTree>
@@ -882,11 +874,7 @@
         <p:txBody>
           <a:bodyPr/>
           <a:lstStyle/>
-          <a:p>
-            <a:r>
-              <a:t>[3:15 · 20 s] [click] A Swiss open model, [click] on Swiss compute, [click] and it runs fully offline in Docker with a local Apertus; we tested it with the network off. [click] Zero tokens per search, [click] about 22 dollars a month to host, [click] half a second to first results. And we crawl politely, never at query time.</a:t>
-            </a:r>
-          </a:p>
+          <a:p/>
         </p:txBody>
       </p:sp>
     </p:spTree>
@@ -952,11 +940,7 @@
         <p:txBody>
           <a:bodyPr/>
           <a:lstStyle/>
-          <a:p>
-            <a:r>
-              <a:t>[3:35 · 20 s] [click] A new institution is one configuration file, no code change. [click×7] And every challenge criterion is covered: right people, different wording, traceability, structured fields, all three sources, extensibility, and it says when it isn't sure.</a:t>
-            </a:r>
-          </a:p>
+          <a:p/>
         </p:txBody>
       </p:sp>
     </p:spTree>
@@ -1022,11 +1006,7 @@
         <p:txBody>
           <a:bodyPr/>
           <a:lstStyle/>
-          <a:p>
-            <a:r>
-              <a:t>[3:55 · 20 s] [click] Production-ready today: one-command deploy and rollback, automated tests, admin, removal, offline in Docker. [click] To go live: Swiss hosting, scheduled refresh, monitoring, sign-on. [click] Next: Swiss embeddings for a full Apertus stack, 1,500 more pages already crawled, and team shortlists.</a:t>
-            </a:r>
-          </a:p>
+          <a:p/>
         </p:txBody>
       </p:sp>
     </p:spTree>
@@ -1092,11 +1072,7 @@
         <p:txBody>
           <a:bodyPr/>
           <a:lstStyle/>
-          <a:p>
-            <a:r>
-              <a:t>[4:15 · 10 s] [click] Bern Match turns 41 websites into a verified shortlist: who to call, why, with proof. [click] Scan the code and try it. Thank you.</a:t>
-            </a:r>
-          </a:p>
+          <a:p/>
         </p:txBody>
       </p:sp>
     </p:spTree>
@@ -1162,11 +1138,7 @@
         <p:txBody>
           <a:bodyPr/>
           <a:lstStyle/>
-          <a:p>
-            <a:r>
-              <a:t>[0:15 · 20 s] [click] Expertise sits on 41 public websites. [click] In four languages. [click] The company asks: who can help with glucose sensors? [click] The lab page says CGM, biosensing, Glukosemessung. [click] Same expertise, different words. Bern Match closes that gap.</a:t>
-            </a:r>
-          </a:p>
+          <a:p/>
         </p:txBody>
       </p:sp>
     </p:spTree>
@@ -1232,11 +1204,7 @@
         <p:txBody>
           <a:bodyPr/>
           <a:lstStyle/>
-          <a:p>
-            <a:r>
-              <a:t>[0:35 · 25 s] Why Bern Match wins. [click] It understands meaning, [click] across 41 sites and four languages, [click] and returns people and groups, not pages. [click] Every claim is quoted from its source, [click] in under a second with zero tokens, [click] on a Swiss model you can run yourself. No other option does all six.</a:t>
-            </a:r>
-          </a:p>
+          <a:p/>
         </p:txBody>
       </p:sp>
     </p:spTree>
@@ -1302,11 +1270,7 @@
         <p:txBody>
           <a:bodyPr/>
           <a:lstStyle/>
-          <a:p>
-            <a:r>
-              <a:t>[1:00 · 75 s] [click] The analyst asks in plain language. [click] Each card is a contact with the exact source sentence and link. [click] The right ones go into the shortlist: notes, PDF, brief, e-mail draft. That shortlist is the product. [click] Let's see it live. LIVE: 'needle-free glucose monitoring for people with diabetes', SPN-005 on top, open its quote; the same need in German, same partner; add three to the shortlist and export the PDF.</a:t>
-            </a:r>
-          </a:p>
+          <a:p/>
         </p:txBody>
       </p:sp>
     </p:spTree>
@@ -1372,11 +1336,7 @@
         <p:txBody>
           <a:bodyPr/>
           <a:lstStyle/>
-          <a:p>
-            <a:r>
-              <a:t>[2:15 · 20 s] [click] The company says 'glucose sensors'. [click] Apertus 70B adds the lab's own words: CGM, continuous glucose monitoring, Glukosemessung. [click] Plain search finds 65% of the expected experts in the top ten. [click] With 8B, 65%. [click] With 70B, 82%, above the 80% target. Every model here was chosen by measurement.</a:t>
-            </a:r>
-          </a:p>
+          <a:p/>
         </p:txBody>
       </p:sp>
     </p:spTree>
@@ -1442,11 +1402,7 @@
         <p:txBody>
           <a:bodyPr/>
           <a:lstStyle/>
-          <a:p>
-            <a:r>
-              <a:t>[2:35 · 20 s] Prepared once: [click] 41 sources, [click] a polite crawl, [click] Apertus extracts facts, each tied to a stored sentence, [click] one index on a CPU. At query time: [click] a request, [click] instant search with no AI, [click] cards with proof, [click] the shortlist. [click] Apertus refines in the background.</a:t>
-            </a:r>
-          </a:p>
+          <a:p/>
         </p:txBody>
       </p:sp>
     </p:spTree>

</xml_diff>